<commit_message>
fix(report): correct failure rate to 14.8% (was overstated as 25%)
The earlier 25% figure was wrong: the test split shows 712 positives
out of 4 809 records (14.8%), not 25%. Update the binary class
imbalance mention in the PDF generator, the PPTX generator and the
README so all artefacts agree with the actual stratified split.
Regenerate PDF (32 pages) and PPTX (12 slides, 0 overlaps audit).
</commit_message>
<xml_diff>
--- a/reports/11/presentation.pptx
+++ b/reports/11/presentation.pptx
@@ -933,7 +933,7 @@
           <a:lstStyle/>
           <a:p>
             <a:r>
-              <a:t>Nous avons travaillé en binôme avec une méthodologie Agile. Le dataset Kaggle CC0 contient 24 042 observations et 15 colonnes. Les deux capteurs les plus discriminants sont la vibration et la température moteur. Le déséquilibre des classes (~25% pannes) justifie notre choix de métriques F1 et PR-AUC.</a:t>
+              <a:t>Nous avons travaillé en binôme avec une méthodologie Agile. Le dataset Kaggle CC0 contient 24 042 observations et 15 colonnes. Les deux capteurs les plus discriminants sont la vibration et la température moteur. Le déséquilibre des classes (~14.8% pannes) justifie notre choix de métriques F1 et PR-AUC.</a:t>
             </a:r>
           </a:p>
         </p:txBody>
@@ -8950,7 +8950,7 @@
                 </a:solidFill>
                 <a:latin typeface="Calibri"/>
               </a:rPr>
-              <a:t>· Déséquilibre : ~25% pannes (justifie F1 + PR-AUC)</a:t>
+              <a:t>· Déséquilibre : ~14.8% pannes (justifie F1 + PR-AUC)</a:t>
             </a:r>
           </a:p>
           <a:p>

</xml_diff>

<commit_message>
fix(slides+dashboard): add hours_since_maintenance row and restore guard
Slide 4 dataset table now lists six columns (added hours_since_maintenance
as a feature row tagged "proxy d'usure"); table position adjusted to
top=4.15" height=2.65" so the audit stays at 0 overlaps / 0 OOB.

Restore the strict streamlit-runtime guard that exits with a clear hint
when somebody runs `python dashboard/app.py` directly. The previous
soft hint allowed the script to keep running and Streamlit flooded the
terminal with `missing ScriptRunContext` warnings — exiting with code 0
right after the hint is the right behaviour.
</commit_message>
<xml_diff>
--- a/reports/11/presentation.pptx
+++ b/reports/11/presentation.pptx
@@ -9031,8 +9031,8 @@
           <p:nvPr/>
         </p:nvGraphicFramePr>
         <p:xfrm>
-          <a:off x="612648" y="3749039"/>
-          <a:ext cx="10972800" cy="2194560"/>
+          <a:off x="612648" y="3794760"/>
+          <a:ext cx="10972800" cy="2423160"/>
         </p:xfrm>
         <a:graphic>
           <a:graphicData uri="http://schemas.openxmlformats.org/drawingml/2006/table">
@@ -9046,7 +9046,7 @@
                 <a:gridCol w="2743200"/>
                 <a:gridCol w="2743200"/>
               </a:tblGrid>
-              <a:tr h="365760">
+              <a:tr h="346165">
                 <a:tc>
                   <a:txBody>
                     <a:bodyPr/>
@@ -9140,7 +9140,7 @@
                   </a:tcPr>
                 </a:tc>
               </a:tr>
-              <a:tr h="365760">
+              <a:tr h="346165">
                 <a:tc>
                   <a:txBody>
                     <a:bodyPr/>
@@ -9234,7 +9234,7 @@
                   </a:tcPr>
                 </a:tc>
               </a:tr>
-              <a:tr h="365760">
+              <a:tr h="346165">
                 <a:tc>
                   <a:txBody>
                     <a:bodyPr/>
@@ -9328,7 +9328,7 @@
                   </a:tcPr>
                 </a:tc>
               </a:tr>
-              <a:tr h="365760">
+              <a:tr h="346165">
                 <a:tc>
                   <a:txBody>
                     <a:bodyPr/>
@@ -9342,195 +9342,7 @@
                           </a:solidFill>
                           <a:latin typeface="Calibri"/>
                         </a:rPr>
-                        <a:t>failure_within_24h</a:t>
-                      </a:r>
-                    </a:p>
-                  </a:txBody>
-                  <a:tcPr>
-                    <a:solidFill>
-                      <a:srgbClr val="FFFFFF"/>
-                    </a:solidFill>
-                  </a:tcPr>
-                </a:tc>
-                <a:tc>
-                  <a:txBody>
-                    <a:bodyPr/>
-                    <a:lstStyle/>
-                    <a:p>
-                      <a:pPr algn="ctr"/>
-                      <a:r>
-                        <a:rPr sz="1100" b="0">
-                          <a:solidFill>
-                            <a:srgbClr val="212121"/>
-                          </a:solidFill>
-                          <a:latin typeface="Calibri"/>
-                        </a:rPr>
-                        <a:t>int 0/1</a:t>
-                      </a:r>
-                    </a:p>
-                  </a:txBody>
-                  <a:tcPr>
-                    <a:solidFill>
-                      <a:srgbClr val="FFFFFF"/>
-                    </a:solidFill>
-                  </a:tcPr>
-                </a:tc>
-                <a:tc>
-                  <a:txBody>
-                    <a:bodyPr/>
-                    <a:lstStyle/>
-                    <a:p>
-                      <a:pPr algn="ctr"/>
-                      <a:r>
-                        <a:rPr sz="1100" b="0">
-                          <a:solidFill>
-                            <a:srgbClr val="212121"/>
-                          </a:solidFill>
-                          <a:latin typeface="Calibri"/>
-                        </a:rPr>
-                        <a:t>-</a:t>
-                      </a:r>
-                    </a:p>
-                  </a:txBody>
-                  <a:tcPr>
-                    <a:solidFill>
-                      <a:srgbClr val="FFFFFF"/>
-                    </a:solidFill>
-                  </a:tcPr>
-                </a:tc>
-                <a:tc>
-                  <a:txBody>
-                    <a:bodyPr/>
-                    <a:lstStyle/>
-                    <a:p>
-                      <a:pPr algn="ctr"/>
-                      <a:r>
-                        <a:rPr sz="1100" b="0">
-                          <a:solidFill>
-                            <a:srgbClr val="212121"/>
-                          </a:solidFill>
-                          <a:latin typeface="Calibri"/>
-                        </a:rPr>
-                        <a:t>Cible binaire principale</a:t>
-                      </a:r>
-                    </a:p>
-                  </a:txBody>
-                  <a:tcPr>
-                    <a:solidFill>
-                      <a:srgbClr val="FFFFFF"/>
-                    </a:solidFill>
-                  </a:tcPr>
-                </a:tc>
-              </a:tr>
-              <a:tr h="365760">
-                <a:tc>
-                  <a:txBody>
-                    <a:bodyPr/>
-                    <a:lstStyle/>
-                    <a:p>
-                      <a:pPr algn="ctr"/>
-                      <a:r>
-                        <a:rPr sz="1100" b="0">
-                          <a:solidFill>
-                            <a:srgbClr val="212121"/>
-                          </a:solidFill>
-                          <a:latin typeface="Calibri"/>
-                        </a:rPr>
-                        <a:t>failure_type</a:t>
-                      </a:r>
-                    </a:p>
-                  </a:txBody>
-                  <a:tcPr>
-                    <a:solidFill>
-                      <a:srgbClr val="F5F7FA"/>
-                    </a:solidFill>
-                  </a:tcPr>
-                </a:tc>
-                <a:tc>
-                  <a:txBody>
-                    <a:bodyPr/>
-                    <a:lstStyle/>
-                    <a:p>
-                      <a:pPr algn="ctr"/>
-                      <a:r>
-                        <a:rPr sz="1100" b="0">
-                          <a:solidFill>
-                            <a:srgbClr val="212121"/>
-                          </a:solidFill>
-                          <a:latin typeface="Calibri"/>
-                        </a:rPr>
-                        <a:t>catégorie</a:t>
-                      </a:r>
-                    </a:p>
-                  </a:txBody>
-                  <a:tcPr>
-                    <a:solidFill>
-                      <a:srgbClr val="F5F7FA"/>
-                    </a:solidFill>
-                  </a:tcPr>
-                </a:tc>
-                <a:tc>
-                  <a:txBody>
-                    <a:bodyPr/>
-                    <a:lstStyle/>
-                    <a:p>
-                      <a:pPr algn="ctr"/>
-                      <a:r>
-                        <a:rPr sz="1100" b="0">
-                          <a:solidFill>
-                            <a:srgbClr val="212121"/>
-                          </a:solidFill>
-                          <a:latin typeface="Calibri"/>
-                        </a:rPr>
-                        <a:t>5 classes</a:t>
-                      </a:r>
-                    </a:p>
-                  </a:txBody>
-                  <a:tcPr>
-                    <a:solidFill>
-                      <a:srgbClr val="F5F7FA"/>
-                    </a:solidFill>
-                  </a:tcPr>
-                </a:tc>
-                <a:tc>
-                  <a:txBody>
-                    <a:bodyPr/>
-                    <a:lstStyle/>
-                    <a:p>
-                      <a:pPr algn="ctr"/>
-                      <a:r>
-                        <a:rPr sz="1100" b="0">
-                          <a:solidFill>
-                            <a:srgbClr val="212121"/>
-                          </a:solidFill>
-                          <a:latin typeface="Calibri"/>
-                        </a:rPr>
-                        <a:t>Cible multiclasse</a:t>
-                      </a:r>
-                    </a:p>
-                  </a:txBody>
-                  <a:tcPr>
-                    <a:solidFill>
-                      <a:srgbClr val="F5F7FA"/>
-                    </a:solidFill>
-                  </a:tcPr>
-                </a:tc>
-              </a:tr>
-              <a:tr h="365760">
-                <a:tc>
-                  <a:txBody>
-                    <a:bodyPr/>
-                    <a:lstStyle/>
-                    <a:p>
-                      <a:pPr algn="ctr"/>
-                      <a:r>
-                        <a:rPr sz="1100" b="0">
-                          <a:solidFill>
-                            <a:srgbClr val="212121"/>
-                          </a:solidFill>
-                          <a:latin typeface="Calibri"/>
-                        </a:rPr>
-                        <a:t>rul_hours</a:t>
+                        <a:t>hours_since_maintenance</a:t>
                       </a:r>
                     </a:p>
                   </a:txBody>
@@ -9599,13 +9411,295 @@
                           </a:solidFill>
                           <a:latin typeface="Calibri"/>
                         </a:rPr>
+                        <a:t>Feature (proxy d'usure)</a:t>
+                      </a:r>
+                    </a:p>
+                  </a:txBody>
+                  <a:tcPr>
+                    <a:solidFill>
+                      <a:srgbClr val="FFFFFF"/>
+                    </a:solidFill>
+                  </a:tcPr>
+                </a:tc>
+              </a:tr>
+              <a:tr h="346165">
+                <a:tc>
+                  <a:txBody>
+                    <a:bodyPr/>
+                    <a:lstStyle/>
+                    <a:p>
+                      <a:pPr algn="ctr"/>
+                      <a:r>
+                        <a:rPr sz="1100" b="0">
+                          <a:solidFill>
+                            <a:srgbClr val="212121"/>
+                          </a:solidFill>
+                          <a:latin typeface="Calibri"/>
+                        </a:rPr>
+                        <a:t>failure_within_24h</a:t>
+                      </a:r>
+                    </a:p>
+                  </a:txBody>
+                  <a:tcPr>
+                    <a:solidFill>
+                      <a:srgbClr val="F5F7FA"/>
+                    </a:solidFill>
+                  </a:tcPr>
+                </a:tc>
+                <a:tc>
+                  <a:txBody>
+                    <a:bodyPr/>
+                    <a:lstStyle/>
+                    <a:p>
+                      <a:pPr algn="ctr"/>
+                      <a:r>
+                        <a:rPr sz="1100" b="0">
+                          <a:solidFill>
+                            <a:srgbClr val="212121"/>
+                          </a:solidFill>
+                          <a:latin typeface="Calibri"/>
+                        </a:rPr>
+                        <a:t>int 0/1</a:t>
+                      </a:r>
+                    </a:p>
+                  </a:txBody>
+                  <a:tcPr>
+                    <a:solidFill>
+                      <a:srgbClr val="F5F7FA"/>
+                    </a:solidFill>
+                  </a:tcPr>
+                </a:tc>
+                <a:tc>
+                  <a:txBody>
+                    <a:bodyPr/>
+                    <a:lstStyle/>
+                    <a:p>
+                      <a:pPr algn="ctr"/>
+                      <a:r>
+                        <a:rPr sz="1100" b="0">
+                          <a:solidFill>
+                            <a:srgbClr val="212121"/>
+                          </a:solidFill>
+                          <a:latin typeface="Calibri"/>
+                        </a:rPr>
+                        <a:t>-</a:t>
+                      </a:r>
+                    </a:p>
+                  </a:txBody>
+                  <a:tcPr>
+                    <a:solidFill>
+                      <a:srgbClr val="F5F7FA"/>
+                    </a:solidFill>
+                  </a:tcPr>
+                </a:tc>
+                <a:tc>
+                  <a:txBody>
+                    <a:bodyPr/>
+                    <a:lstStyle/>
+                    <a:p>
+                      <a:pPr algn="ctr"/>
+                      <a:r>
+                        <a:rPr sz="1100" b="0">
+                          <a:solidFill>
+                            <a:srgbClr val="212121"/>
+                          </a:solidFill>
+                          <a:latin typeface="Calibri"/>
+                        </a:rPr>
+                        <a:t>Cible binaire principale</a:t>
+                      </a:r>
+                    </a:p>
+                  </a:txBody>
+                  <a:tcPr>
+                    <a:solidFill>
+                      <a:srgbClr val="F5F7FA"/>
+                    </a:solidFill>
+                  </a:tcPr>
+                </a:tc>
+              </a:tr>
+              <a:tr h="346165">
+                <a:tc>
+                  <a:txBody>
+                    <a:bodyPr/>
+                    <a:lstStyle/>
+                    <a:p>
+                      <a:pPr algn="ctr"/>
+                      <a:r>
+                        <a:rPr sz="1100" b="0">
+                          <a:solidFill>
+                            <a:srgbClr val="212121"/>
+                          </a:solidFill>
+                          <a:latin typeface="Calibri"/>
+                        </a:rPr>
+                        <a:t>failure_type</a:t>
+                      </a:r>
+                    </a:p>
+                  </a:txBody>
+                  <a:tcPr>
+                    <a:solidFill>
+                      <a:srgbClr val="FFFFFF"/>
+                    </a:solidFill>
+                  </a:tcPr>
+                </a:tc>
+                <a:tc>
+                  <a:txBody>
+                    <a:bodyPr/>
+                    <a:lstStyle/>
+                    <a:p>
+                      <a:pPr algn="ctr"/>
+                      <a:r>
+                        <a:rPr sz="1100" b="0">
+                          <a:solidFill>
+                            <a:srgbClr val="212121"/>
+                          </a:solidFill>
+                          <a:latin typeface="Calibri"/>
+                        </a:rPr>
+                        <a:t>catégorie</a:t>
+                      </a:r>
+                    </a:p>
+                  </a:txBody>
+                  <a:tcPr>
+                    <a:solidFill>
+                      <a:srgbClr val="FFFFFF"/>
+                    </a:solidFill>
+                  </a:tcPr>
+                </a:tc>
+                <a:tc>
+                  <a:txBody>
+                    <a:bodyPr/>
+                    <a:lstStyle/>
+                    <a:p>
+                      <a:pPr algn="ctr"/>
+                      <a:r>
+                        <a:rPr sz="1100" b="0">
+                          <a:solidFill>
+                            <a:srgbClr val="212121"/>
+                          </a:solidFill>
+                          <a:latin typeface="Calibri"/>
+                        </a:rPr>
+                        <a:t>5 classes</a:t>
+                      </a:r>
+                    </a:p>
+                  </a:txBody>
+                  <a:tcPr>
+                    <a:solidFill>
+                      <a:srgbClr val="FFFFFF"/>
+                    </a:solidFill>
+                  </a:tcPr>
+                </a:tc>
+                <a:tc>
+                  <a:txBody>
+                    <a:bodyPr/>
+                    <a:lstStyle/>
+                    <a:p>
+                      <a:pPr algn="ctr"/>
+                      <a:r>
+                        <a:rPr sz="1100" b="0">
+                          <a:solidFill>
+                            <a:srgbClr val="212121"/>
+                          </a:solidFill>
+                          <a:latin typeface="Calibri"/>
+                        </a:rPr>
+                        <a:t>Cible multiclasse</a:t>
+                      </a:r>
+                    </a:p>
+                  </a:txBody>
+                  <a:tcPr>
+                    <a:solidFill>
+                      <a:srgbClr val="FFFFFF"/>
+                    </a:solidFill>
+                  </a:tcPr>
+                </a:tc>
+              </a:tr>
+              <a:tr h="346170">
+                <a:tc>
+                  <a:txBody>
+                    <a:bodyPr/>
+                    <a:lstStyle/>
+                    <a:p>
+                      <a:pPr algn="ctr"/>
+                      <a:r>
+                        <a:rPr sz="1100" b="0">
+                          <a:solidFill>
+                            <a:srgbClr val="212121"/>
+                          </a:solidFill>
+                          <a:latin typeface="Calibri"/>
+                        </a:rPr>
+                        <a:t>rul_hours</a:t>
+                      </a:r>
+                    </a:p>
+                  </a:txBody>
+                  <a:tcPr>
+                    <a:solidFill>
+                      <a:srgbClr val="F5F7FA"/>
+                    </a:solidFill>
+                  </a:tcPr>
+                </a:tc>
+                <a:tc>
+                  <a:txBody>
+                    <a:bodyPr/>
+                    <a:lstStyle/>
+                    <a:p>
+                      <a:pPr algn="ctr"/>
+                      <a:r>
+                        <a:rPr sz="1100" b="0">
+                          <a:solidFill>
+                            <a:srgbClr val="212121"/>
+                          </a:solidFill>
+                          <a:latin typeface="Calibri"/>
+                        </a:rPr>
+                        <a:t>float</a:t>
+                      </a:r>
+                    </a:p>
+                  </a:txBody>
+                  <a:tcPr>
+                    <a:solidFill>
+                      <a:srgbClr val="F5F7FA"/>
+                    </a:solidFill>
+                  </a:tcPr>
+                </a:tc>
+                <a:tc>
+                  <a:txBody>
+                    <a:bodyPr/>
+                    <a:lstStyle/>
+                    <a:p>
+                      <a:pPr algn="ctr"/>
+                      <a:r>
+                        <a:rPr sz="1100" b="0">
+                          <a:solidFill>
+                            <a:srgbClr val="212121"/>
+                          </a:solidFill>
+                          <a:latin typeface="Calibri"/>
+                        </a:rPr>
+                        <a:t>h</a:t>
+                      </a:r>
+                    </a:p>
+                  </a:txBody>
+                  <a:tcPr>
+                    <a:solidFill>
+                      <a:srgbClr val="F5F7FA"/>
+                    </a:solidFill>
+                  </a:tcPr>
+                </a:tc>
+                <a:tc>
+                  <a:txBody>
+                    <a:bodyPr/>
+                    <a:lstStyle/>
+                    <a:p>
+                      <a:pPr algn="ctr"/>
+                      <a:r>
+                        <a:rPr sz="1100" b="0">
+                          <a:solidFill>
+                            <a:srgbClr val="212121"/>
+                          </a:solidFill>
+                          <a:latin typeface="Calibri"/>
+                        </a:rPr>
                         <a:t>Cible régression (durée vie restante)</a:t>
                       </a:r>
                     </a:p>
                   </a:txBody>
                   <a:tcPr>
                     <a:solidFill>
-                      <a:srgbClr val="FFFFFF"/>
+                      <a:srgbClr val="F5F7FA"/>
                     </a:solidFill>
                   </a:tcPr>
                 </a:tc>

</xml_diff>

<commit_message>
chore(privacy+orchestrator): drop Adam student id from artefacts, verbose deps
Remove the student number 20220055 from the cover of the PDF report,
the title and Q&A footer of the PPTX, and the Authors line in README.
Emilien's number stays untouched (Adam asked only for his own to go).
Regenerate the deliverables (PDF 32 pages, PPTX 12 slides, audit 0/0).

The orchestrator app.py now calls ensure_dependencies(verbose=True) and
prints a clear "[0/3] Verification des dependances" banner so a fresh
clone sees pip installing missing packages on first launch instead of
crashing on a ModuleNotFoundError later.
</commit_message>
<xml_diff>
--- a/reports/11/presentation.pptx
+++ b/reports/11/presentation.pptx
@@ -4569,7 +4569,7 @@
                 </a:solidFill>
                 <a:latin typeface="Calibri"/>
               </a:rPr>
-              <a:t>Adam BELOUCIF (20220055)  ·  Emilien MORICE</a:t>
+              <a:t>Adam BELOUCIF  ·  Emilien MORICE</a:t>
             </a:r>
           </a:p>
         </p:txBody>
@@ -6906,7 +6906,7 @@
                 </a:solidFill>
                 <a:latin typeface="Calibri"/>
               </a:rPr>
-              <a:t>Adam BELOUCIF 20220055  ·  Emilien MORICE  ·  M1 DE&amp;IA EFREI 2025-2026</a:t>
+              <a:t>Adam BELOUCIF  ·  Emilien MORICE  ·  M1 DE&amp;IA EFREI 2025-2026</a:t>
             </a:r>
           </a:p>
         </p:txBody>

</xml_diff>

<commit_message>
build: regenerate PDF report + PPTX with real metrics (XGBoost F1=0.886 ROC-AUC=0.995)
</commit_message>
<xml_diff>
--- a/reports/11/presentation.pptx
+++ b/reports/11/presentation.pptx
@@ -4912,68 +4912,9 @@
           </a:p>
         </p:txBody>
       </p:sp>
-      <p:pic>
-        <p:nvPicPr>
-          <p:cNvPr id="9" name="Picture 8" descr="cost_threshold_xgboost.png"/>
-          <p:cNvPicPr>
-            <a:picLocks noChangeAspect="1"/>
-          </p:cNvPicPr>
-          <p:nvPr/>
-        </p:nvPicPr>
-        <p:blipFill>
-          <a:blip r:embed="rId3"/>
-          <a:stretch>
-            <a:fillRect/>
-          </a:stretch>
-        </p:blipFill>
-        <p:spPr>
-          <a:xfrm>
-            <a:off x="457200" y="1097280"/>
-            <a:ext cx="3866546" cy="2560320"/>
-          </a:xfrm>
-          <a:prstGeom prst="rect">
-            <a:avLst/>
-          </a:prstGeom>
-        </p:spPr>
-      </p:pic>
-      <p:sp>
-        <p:nvSpPr>
-          <p:cNvPr id="10" name="TextBox 9"/>
-          <p:cNvSpPr txBox="1"/>
-          <p:nvPr/>
-        </p:nvSpPr>
-        <p:spPr>
-          <a:xfrm>
-            <a:off x="457200" y="3730752"/>
-            <a:ext cx="3866546" cy="274320"/>
-          </a:xfrm>
-          <a:prstGeom prst="rect">
-            <a:avLst/>
-          </a:prstGeom>
-          <a:noFill/>
-        </p:spPr>
-        <p:txBody>
-          <a:bodyPr wrap="square">
-            <a:spAutoFit/>
-          </a:bodyPr>
-          <a:lstStyle/>
-          <a:p>
-            <a:pPr algn="ctr"/>
-            <a:r>
-              <a:rPr sz="1100" b="0" i="1">
-                <a:solidFill>
-                  <a:srgbClr val="6B7280"/>
-                </a:solidFill>
-                <a:latin typeface="Calibri"/>
-              </a:rPr>
-              <a:t>Courbe coût(seuil) XGBoost · minimum à 0.23</a:t>
-            </a:r>
-          </a:p>
-        </p:txBody>
-      </p:sp>
-      <p:sp>
-        <p:nvSpPr>
-          <p:cNvPr id="11" name="Rectangle 10"/>
+      <p:sp>
+        <p:nvSpPr>
+          <p:cNvPr id="9" name="Rectangle 8"/>
           <p:cNvSpPr/>
           <p:nvPr/>
         </p:nvSpPr>
@@ -5018,7 +4959,7 @@
       </p:sp>
       <p:sp>
         <p:nvSpPr>
-          <p:cNvPr id="12" name="TextBox 11"/>
+          <p:cNvPr id="10" name="TextBox 9"/>
           <p:cNvSpPr txBox="1"/>
           <p:nvPr/>
         </p:nvSpPr>
@@ -5055,7 +4996,7 @@
       </p:sp>
       <p:sp>
         <p:nvSpPr>
-          <p:cNvPr id="13" name="TextBox 12"/>
+          <p:cNvPr id="11" name="TextBox 10"/>
           <p:cNvSpPr txBox="1"/>
           <p:nvPr/>
         </p:nvSpPr>
@@ -5090,7 +5031,7 @@
       </p:sp>
       <p:sp>
         <p:nvSpPr>
-          <p:cNvPr id="14" name="TextBox 13"/>
+          <p:cNvPr id="12" name="TextBox 11"/>
           <p:cNvSpPr txBox="1"/>
           <p:nvPr/>
         </p:nvSpPr>
@@ -5193,7 +5134,7 @@
       </p:sp>
       <p:sp>
         <p:nvSpPr>
-          <p:cNvPr id="15" name="TextBox 14"/>
+          <p:cNvPr id="13" name="TextBox 12"/>
           <p:cNvSpPr txBox="1"/>
           <p:nvPr/>
         </p:nvSpPr>
@@ -5228,7 +5169,7 @@
       </p:sp>
       <p:graphicFrame>
         <p:nvGraphicFramePr>
-          <p:cNvPr id="16" name="Table 15"/>
+          <p:cNvPr id="14" name="Table 13"/>
           <p:cNvGraphicFramePr>
             <a:graphicFrameLocks noGrp="1"/>
           </p:cNvGraphicFramePr>
@@ -5610,7 +5551,7 @@
       </p:graphicFrame>
       <p:sp>
         <p:nvSpPr>
-          <p:cNvPr id="17" name="TextBox 16"/>
+          <p:cNvPr id="15" name="TextBox 14"/>
           <p:cNvSpPr txBox="1"/>
           <p:nvPr/>
         </p:nvSpPr>
@@ -10012,124 +9953,6 @@
           </a:p>
         </p:txBody>
       </p:sp>
-      <p:pic>
-        <p:nvPicPr>
-          <p:cNvPr id="9" name="Picture 8" descr="eda_correlation_heatmap.png"/>
-          <p:cNvPicPr>
-            <a:picLocks noChangeAspect="1"/>
-          </p:cNvPicPr>
-          <p:nvPr/>
-        </p:nvPicPr>
-        <p:blipFill>
-          <a:blip r:embed="rId3"/>
-          <a:stretch>
-            <a:fillRect/>
-          </a:stretch>
-        </p:blipFill>
-        <p:spPr>
-          <a:xfrm>
-            <a:off x="457200" y="1508760"/>
-            <a:ext cx="4578482" cy="4114800"/>
-          </a:xfrm>
-          <a:prstGeom prst="rect">
-            <a:avLst/>
-          </a:prstGeom>
-        </p:spPr>
-      </p:pic>
-      <p:sp>
-        <p:nvSpPr>
-          <p:cNvPr id="10" name="TextBox 9"/>
-          <p:cNvSpPr txBox="1"/>
-          <p:nvPr/>
-        </p:nvSpPr>
-        <p:spPr>
-          <a:xfrm>
-            <a:off x="457200" y="5696712"/>
-            <a:ext cx="4578482" cy="274320"/>
-          </a:xfrm>
-          <a:prstGeom prst="rect">
-            <a:avLst/>
-          </a:prstGeom>
-          <a:noFill/>
-        </p:spPr>
-        <p:txBody>
-          <a:bodyPr wrap="square">
-            <a:spAutoFit/>
-          </a:bodyPr>
-          <a:lstStyle/>
-          <a:p>
-            <a:pPr algn="ctr"/>
-            <a:r>
-              <a:rPr sz="1100" b="0" i="1">
-                <a:solidFill>
-                  <a:srgbClr val="6B7280"/>
-                </a:solidFill>
-                <a:latin typeface="Calibri"/>
-              </a:rPr>
-              <a:t>Matrice de corrélation capteurs x cible binaire</a:t>
-            </a:r>
-          </a:p>
-        </p:txBody>
-      </p:sp>
-      <p:pic>
-        <p:nvPicPr>
-          <p:cNvPr id="11" name="Picture 10" descr="eda_scatter_vib_temp.png"/>
-          <p:cNvPicPr>
-            <a:picLocks noChangeAspect="1"/>
-          </p:cNvPicPr>
-          <p:nvPr/>
-        </p:nvPicPr>
-        <p:blipFill>
-          <a:blip r:embed="rId4"/>
-          <a:stretch>
-            <a:fillRect/>
-          </a:stretch>
-        </p:blipFill>
-        <p:spPr>
-          <a:xfrm>
-            <a:off x="6245352" y="1508760"/>
-            <a:ext cx="5303520" cy="3677203"/>
-          </a:xfrm>
-          <a:prstGeom prst="rect">
-            <a:avLst/>
-          </a:prstGeom>
-        </p:spPr>
-      </p:pic>
-      <p:sp>
-        <p:nvSpPr>
-          <p:cNvPr id="12" name="TextBox 11"/>
-          <p:cNvSpPr txBox="1"/>
-          <p:nvPr/>
-        </p:nvSpPr>
-        <p:spPr>
-          <a:xfrm>
-            <a:off x="6245352" y="5259115"/>
-            <a:ext cx="5303520" cy="274320"/>
-          </a:xfrm>
-          <a:prstGeom prst="rect">
-            <a:avLst/>
-          </a:prstGeom>
-          <a:noFill/>
-        </p:spPr>
-        <p:txBody>
-          <a:bodyPr wrap="square">
-            <a:spAutoFit/>
-          </a:bodyPr>
-          <a:lstStyle/>
-          <a:p>
-            <a:pPr algn="ctr"/>
-            <a:r>
-              <a:rPr sz="1100" b="0" i="1">
-                <a:solidFill>
-                  <a:srgbClr val="6B7280"/>
-                </a:solidFill>
-                <a:latin typeface="Calibri"/>
-              </a:rPr>
-              <a:t>Scatter vibration x température (zone haute droite = pannes)</a:t>
-            </a:r>
-          </a:p>
-        </p:txBody>
-      </p:sp>
     </p:spTree>
   </p:cSld>
   <p:clrMapOvr>
@@ -10450,40 +10273,16 @@
           </a:p>
         </p:txBody>
       </p:sp>
-      <p:pic>
-        <p:nvPicPr>
-          <p:cNvPr id="9" name="Picture 8" descr="diagram_ml_pipeline.png"/>
-          <p:cNvPicPr>
-            <a:picLocks noChangeAspect="1"/>
-          </p:cNvPicPr>
-          <p:nvPr/>
-        </p:nvPicPr>
-        <p:blipFill>
-          <a:blip r:embed="rId3"/>
-          <a:stretch>
-            <a:fillRect/>
-          </a:stretch>
-        </p:blipFill>
-        <p:spPr>
-          <a:xfrm>
-            <a:off x="5486400" y="685800"/>
-            <a:ext cx="6400800" cy="2026152"/>
-          </a:xfrm>
-          <a:prstGeom prst="rect">
-            <a:avLst/>
-          </a:prstGeom>
-        </p:spPr>
-      </p:pic>
-      <p:sp>
-        <p:nvSpPr>
-          <p:cNvPr id="10" name="TextBox 9"/>
+      <p:sp>
+        <p:nvSpPr>
+          <p:cNvPr id="9" name="TextBox 8"/>
           <p:cNvSpPr txBox="1"/>
           <p:nvPr/>
         </p:nvSpPr>
         <p:spPr>
           <a:xfrm>
-            <a:off x="5486400" y="2785104"/>
-            <a:ext cx="6400800" cy="274320"/>
+            <a:off x="274320" y="2743200"/>
+            <a:ext cx="5029200" cy="365760"/>
           </a:xfrm>
           <a:prstGeom prst="rect">
             <a:avLst/>
@@ -10496,41 +10295,6 @@
           </a:bodyPr>
           <a:lstStyle/>
           <a:p>
-            <a:pPr algn="ctr"/>
-            <a:r>
-              <a:rPr sz="1100" b="0" i="1">
-                <a:solidFill>
-                  <a:srgbClr val="6B7280"/>
-                </a:solidFill>
-                <a:latin typeface="Calibri"/>
-              </a:rPr>
-              <a:t>Diagramme pipeline ML (preprocessing + train + éval)</a:t>
-            </a:r>
-          </a:p>
-        </p:txBody>
-      </p:sp>
-      <p:sp>
-        <p:nvSpPr>
-          <p:cNvPr id="11" name="TextBox 10"/>
-          <p:cNvSpPr txBox="1"/>
-          <p:nvPr/>
-        </p:nvSpPr>
-        <p:spPr>
-          <a:xfrm>
-            <a:off x="274320" y="2743200"/>
-            <a:ext cx="5029200" cy="365760"/>
-          </a:xfrm>
-          <a:prstGeom prst="rect">
-            <a:avLst/>
-          </a:prstGeom>
-          <a:noFill/>
-        </p:spPr>
-        <p:txBody>
-          <a:bodyPr wrap="square">
-            <a:spAutoFit/>
-          </a:bodyPr>
-          <a:lstStyle/>
-          <a:p>
             <a:pPr algn="l"/>
             <a:r>
               <a:rPr sz="1400" b="1" i="0">
@@ -10546,7 +10310,7 @@
       </p:sp>
       <p:graphicFrame>
         <p:nvGraphicFramePr>
-          <p:cNvPr id="12" name="Table 11"/>
+          <p:cNvPr id="10" name="Table 9"/>
           <p:cNvGraphicFramePr>
             <a:graphicFrameLocks noGrp="1"/>
           </p:cNvGraphicFramePr>

</xml_diff>

<commit_message>
build: regenerate PDF report + PPTX with real metrics (XGBoost F1=0.886 ROC-AUC=0.995) (#4)
</commit_message>
<xml_diff>
--- a/reports/11/presentation.pptx
+++ b/reports/11/presentation.pptx
@@ -4912,68 +4912,9 @@
           </a:p>
         </p:txBody>
       </p:sp>
-      <p:pic>
-        <p:nvPicPr>
-          <p:cNvPr id="9" name="Picture 8" descr="cost_threshold_xgboost.png"/>
-          <p:cNvPicPr>
-            <a:picLocks noChangeAspect="1"/>
-          </p:cNvPicPr>
-          <p:nvPr/>
-        </p:nvPicPr>
-        <p:blipFill>
-          <a:blip r:embed="rId3"/>
-          <a:stretch>
-            <a:fillRect/>
-          </a:stretch>
-        </p:blipFill>
-        <p:spPr>
-          <a:xfrm>
-            <a:off x="457200" y="1097280"/>
-            <a:ext cx="3866546" cy="2560320"/>
-          </a:xfrm>
-          <a:prstGeom prst="rect">
-            <a:avLst/>
-          </a:prstGeom>
-        </p:spPr>
-      </p:pic>
-      <p:sp>
-        <p:nvSpPr>
-          <p:cNvPr id="10" name="TextBox 9"/>
-          <p:cNvSpPr txBox="1"/>
-          <p:nvPr/>
-        </p:nvSpPr>
-        <p:spPr>
-          <a:xfrm>
-            <a:off x="457200" y="3730752"/>
-            <a:ext cx="3866546" cy="274320"/>
-          </a:xfrm>
-          <a:prstGeom prst="rect">
-            <a:avLst/>
-          </a:prstGeom>
-          <a:noFill/>
-        </p:spPr>
-        <p:txBody>
-          <a:bodyPr wrap="square">
-            <a:spAutoFit/>
-          </a:bodyPr>
-          <a:lstStyle/>
-          <a:p>
-            <a:pPr algn="ctr"/>
-            <a:r>
-              <a:rPr sz="1100" b="0" i="1">
-                <a:solidFill>
-                  <a:srgbClr val="6B7280"/>
-                </a:solidFill>
-                <a:latin typeface="Calibri"/>
-              </a:rPr>
-              <a:t>Courbe coût(seuil) XGBoost · minimum à 0.23</a:t>
-            </a:r>
-          </a:p>
-        </p:txBody>
-      </p:sp>
-      <p:sp>
-        <p:nvSpPr>
-          <p:cNvPr id="11" name="Rectangle 10"/>
+      <p:sp>
+        <p:nvSpPr>
+          <p:cNvPr id="9" name="Rectangle 8"/>
           <p:cNvSpPr/>
           <p:nvPr/>
         </p:nvSpPr>
@@ -5018,7 +4959,7 @@
       </p:sp>
       <p:sp>
         <p:nvSpPr>
-          <p:cNvPr id="12" name="TextBox 11"/>
+          <p:cNvPr id="10" name="TextBox 9"/>
           <p:cNvSpPr txBox="1"/>
           <p:nvPr/>
         </p:nvSpPr>
@@ -5055,7 +4996,7 @@
       </p:sp>
       <p:sp>
         <p:nvSpPr>
-          <p:cNvPr id="13" name="TextBox 12"/>
+          <p:cNvPr id="11" name="TextBox 10"/>
           <p:cNvSpPr txBox="1"/>
           <p:nvPr/>
         </p:nvSpPr>
@@ -5090,7 +5031,7 @@
       </p:sp>
       <p:sp>
         <p:nvSpPr>
-          <p:cNvPr id="14" name="TextBox 13"/>
+          <p:cNvPr id="12" name="TextBox 11"/>
           <p:cNvSpPr txBox="1"/>
           <p:nvPr/>
         </p:nvSpPr>
@@ -5193,7 +5134,7 @@
       </p:sp>
       <p:sp>
         <p:nvSpPr>
-          <p:cNvPr id="15" name="TextBox 14"/>
+          <p:cNvPr id="13" name="TextBox 12"/>
           <p:cNvSpPr txBox="1"/>
           <p:nvPr/>
         </p:nvSpPr>
@@ -5228,7 +5169,7 @@
       </p:sp>
       <p:graphicFrame>
         <p:nvGraphicFramePr>
-          <p:cNvPr id="16" name="Table 15"/>
+          <p:cNvPr id="14" name="Table 13"/>
           <p:cNvGraphicFramePr>
             <a:graphicFrameLocks noGrp="1"/>
           </p:cNvGraphicFramePr>
@@ -5610,7 +5551,7 @@
       </p:graphicFrame>
       <p:sp>
         <p:nvSpPr>
-          <p:cNvPr id="17" name="TextBox 16"/>
+          <p:cNvPr id="15" name="TextBox 14"/>
           <p:cNvSpPr txBox="1"/>
           <p:nvPr/>
         </p:nvSpPr>
@@ -10012,124 +9953,6 @@
           </a:p>
         </p:txBody>
       </p:sp>
-      <p:pic>
-        <p:nvPicPr>
-          <p:cNvPr id="9" name="Picture 8" descr="eda_correlation_heatmap.png"/>
-          <p:cNvPicPr>
-            <a:picLocks noChangeAspect="1"/>
-          </p:cNvPicPr>
-          <p:nvPr/>
-        </p:nvPicPr>
-        <p:blipFill>
-          <a:blip r:embed="rId3"/>
-          <a:stretch>
-            <a:fillRect/>
-          </a:stretch>
-        </p:blipFill>
-        <p:spPr>
-          <a:xfrm>
-            <a:off x="457200" y="1508760"/>
-            <a:ext cx="4578482" cy="4114800"/>
-          </a:xfrm>
-          <a:prstGeom prst="rect">
-            <a:avLst/>
-          </a:prstGeom>
-        </p:spPr>
-      </p:pic>
-      <p:sp>
-        <p:nvSpPr>
-          <p:cNvPr id="10" name="TextBox 9"/>
-          <p:cNvSpPr txBox="1"/>
-          <p:nvPr/>
-        </p:nvSpPr>
-        <p:spPr>
-          <a:xfrm>
-            <a:off x="457200" y="5696712"/>
-            <a:ext cx="4578482" cy="274320"/>
-          </a:xfrm>
-          <a:prstGeom prst="rect">
-            <a:avLst/>
-          </a:prstGeom>
-          <a:noFill/>
-        </p:spPr>
-        <p:txBody>
-          <a:bodyPr wrap="square">
-            <a:spAutoFit/>
-          </a:bodyPr>
-          <a:lstStyle/>
-          <a:p>
-            <a:pPr algn="ctr"/>
-            <a:r>
-              <a:rPr sz="1100" b="0" i="1">
-                <a:solidFill>
-                  <a:srgbClr val="6B7280"/>
-                </a:solidFill>
-                <a:latin typeface="Calibri"/>
-              </a:rPr>
-              <a:t>Matrice de corrélation capteurs x cible binaire</a:t>
-            </a:r>
-          </a:p>
-        </p:txBody>
-      </p:sp>
-      <p:pic>
-        <p:nvPicPr>
-          <p:cNvPr id="11" name="Picture 10" descr="eda_scatter_vib_temp.png"/>
-          <p:cNvPicPr>
-            <a:picLocks noChangeAspect="1"/>
-          </p:cNvPicPr>
-          <p:nvPr/>
-        </p:nvPicPr>
-        <p:blipFill>
-          <a:blip r:embed="rId4"/>
-          <a:stretch>
-            <a:fillRect/>
-          </a:stretch>
-        </p:blipFill>
-        <p:spPr>
-          <a:xfrm>
-            <a:off x="6245352" y="1508760"/>
-            <a:ext cx="5303520" cy="3677203"/>
-          </a:xfrm>
-          <a:prstGeom prst="rect">
-            <a:avLst/>
-          </a:prstGeom>
-        </p:spPr>
-      </p:pic>
-      <p:sp>
-        <p:nvSpPr>
-          <p:cNvPr id="12" name="TextBox 11"/>
-          <p:cNvSpPr txBox="1"/>
-          <p:nvPr/>
-        </p:nvSpPr>
-        <p:spPr>
-          <a:xfrm>
-            <a:off x="6245352" y="5259115"/>
-            <a:ext cx="5303520" cy="274320"/>
-          </a:xfrm>
-          <a:prstGeom prst="rect">
-            <a:avLst/>
-          </a:prstGeom>
-          <a:noFill/>
-        </p:spPr>
-        <p:txBody>
-          <a:bodyPr wrap="square">
-            <a:spAutoFit/>
-          </a:bodyPr>
-          <a:lstStyle/>
-          <a:p>
-            <a:pPr algn="ctr"/>
-            <a:r>
-              <a:rPr sz="1100" b="0" i="1">
-                <a:solidFill>
-                  <a:srgbClr val="6B7280"/>
-                </a:solidFill>
-                <a:latin typeface="Calibri"/>
-              </a:rPr>
-              <a:t>Scatter vibration x température (zone haute droite = pannes)</a:t>
-            </a:r>
-          </a:p>
-        </p:txBody>
-      </p:sp>
     </p:spTree>
   </p:cSld>
   <p:clrMapOvr>
@@ -10450,40 +10273,16 @@
           </a:p>
         </p:txBody>
       </p:sp>
-      <p:pic>
-        <p:nvPicPr>
-          <p:cNvPr id="9" name="Picture 8" descr="diagram_ml_pipeline.png"/>
-          <p:cNvPicPr>
-            <a:picLocks noChangeAspect="1"/>
-          </p:cNvPicPr>
-          <p:nvPr/>
-        </p:nvPicPr>
-        <p:blipFill>
-          <a:blip r:embed="rId3"/>
-          <a:stretch>
-            <a:fillRect/>
-          </a:stretch>
-        </p:blipFill>
-        <p:spPr>
-          <a:xfrm>
-            <a:off x="5486400" y="685800"/>
-            <a:ext cx="6400800" cy="2026152"/>
-          </a:xfrm>
-          <a:prstGeom prst="rect">
-            <a:avLst/>
-          </a:prstGeom>
-        </p:spPr>
-      </p:pic>
-      <p:sp>
-        <p:nvSpPr>
-          <p:cNvPr id="10" name="TextBox 9"/>
+      <p:sp>
+        <p:nvSpPr>
+          <p:cNvPr id="9" name="TextBox 8"/>
           <p:cNvSpPr txBox="1"/>
           <p:nvPr/>
         </p:nvSpPr>
         <p:spPr>
           <a:xfrm>
-            <a:off x="5486400" y="2785104"/>
-            <a:ext cx="6400800" cy="274320"/>
+            <a:off x="274320" y="2743200"/>
+            <a:ext cx="5029200" cy="365760"/>
           </a:xfrm>
           <a:prstGeom prst="rect">
             <a:avLst/>
@@ -10496,41 +10295,6 @@
           </a:bodyPr>
           <a:lstStyle/>
           <a:p>
-            <a:pPr algn="ctr"/>
-            <a:r>
-              <a:rPr sz="1100" b="0" i="1">
-                <a:solidFill>
-                  <a:srgbClr val="6B7280"/>
-                </a:solidFill>
-                <a:latin typeface="Calibri"/>
-              </a:rPr>
-              <a:t>Diagramme pipeline ML (preprocessing + train + éval)</a:t>
-            </a:r>
-          </a:p>
-        </p:txBody>
-      </p:sp>
-      <p:sp>
-        <p:nvSpPr>
-          <p:cNvPr id="11" name="TextBox 10"/>
-          <p:cNvSpPr txBox="1"/>
-          <p:nvPr/>
-        </p:nvSpPr>
-        <p:spPr>
-          <a:xfrm>
-            <a:off x="274320" y="2743200"/>
-            <a:ext cx="5029200" cy="365760"/>
-          </a:xfrm>
-          <a:prstGeom prst="rect">
-            <a:avLst/>
-          </a:prstGeom>
-          <a:noFill/>
-        </p:spPr>
-        <p:txBody>
-          <a:bodyPr wrap="square">
-            <a:spAutoFit/>
-          </a:bodyPr>
-          <a:lstStyle/>
-          <a:p>
             <a:pPr algn="l"/>
             <a:r>
               <a:rPr sz="1400" b="1" i="0">
@@ -10546,7 +10310,7 @@
       </p:sp>
       <p:graphicFrame>
         <p:nvGraphicFramePr>
-          <p:cNvPr id="12" name="Table 11"/>
+          <p:cNvPr id="10" name="Table 9"/>
           <p:cNvGraphicFramePr>
             <a:graphicFrameLocks noGrp="1"/>
           </p:cNvGraphicFramePr>

</xml_diff>